<commit_message>
Minor changes Chunk 10
</commit_message>
<xml_diff>
--- a/Lectures/Chunk 10 - 2D numpy and mpl.pptx
+++ b/Lectures/Chunk 10 - 2D numpy and mpl.pptx
@@ -222,12 +222,12 @@
   <pc:docChgLst>
     <pc:chgData name="Jonathan Bollig" userId="8b5d0afe-f106-45e0-8c3f-fd98fa124db1" providerId="ADAL" clId="{B2469FA9-EBD8-4834-A16D-CBF8EFC907DD}"/>
     <pc:docChg chg="undo custSel addSld delSld modSld">
-      <pc:chgData name="Jonathan Bollig" userId="8b5d0afe-f106-45e0-8c3f-fd98fa124db1" providerId="ADAL" clId="{B2469FA9-EBD8-4834-A16D-CBF8EFC907DD}" dt="2025-10-06T21:38:19.489" v="1860" actId="47"/>
+      <pc:chgData name="Jonathan Bollig" userId="8b5d0afe-f106-45e0-8c3f-fd98fa124db1" providerId="ADAL" clId="{B2469FA9-EBD8-4834-A16D-CBF8EFC907DD}" dt="2025-10-07T16:42:13.436" v="1862" actId="20577"/>
       <pc:docMkLst>
         <pc:docMk/>
       </pc:docMkLst>
       <pc:sldChg chg="modSp mod">
-        <pc:chgData name="Jonathan Bollig" userId="8b5d0afe-f106-45e0-8c3f-fd98fa124db1" providerId="ADAL" clId="{B2469FA9-EBD8-4834-A16D-CBF8EFC907DD}" dt="2025-10-06T15:19:50.968" v="1478" actId="20577"/>
+        <pc:chgData name="Jonathan Bollig" userId="8b5d0afe-f106-45e0-8c3f-fd98fa124db1" providerId="ADAL" clId="{B2469FA9-EBD8-4834-A16D-CBF8EFC907DD}" dt="2025-10-07T16:42:13.436" v="1862" actId="20577"/>
         <pc:sldMkLst>
           <pc:docMk/>
           <pc:sldMk cId="836289018" sldId="256"/>
@@ -241,7 +241,7 @@
           </ac:spMkLst>
         </pc:spChg>
         <pc:spChg chg="mod">
-          <ac:chgData name="Jonathan Bollig" userId="8b5d0afe-f106-45e0-8c3f-fd98fa124db1" providerId="ADAL" clId="{B2469FA9-EBD8-4834-A16D-CBF8EFC907DD}" dt="2025-10-06T13:27:25.224" v="281" actId="790"/>
+          <ac:chgData name="Jonathan Bollig" userId="8b5d0afe-f106-45e0-8c3f-fd98fa124db1" providerId="ADAL" clId="{B2469FA9-EBD8-4834-A16D-CBF8EFC907DD}" dt="2025-10-07T16:42:13.436" v="1862" actId="20577"/>
           <ac:spMkLst>
             <pc:docMk/>
             <pc:sldMk cId="836289018" sldId="256"/>
@@ -927,7 +927,7 @@
           <a:p>
             <a:fld id="{0B6CA2EE-5589-4682-AD7F-744DBF1E81F5}" type="datetimeFigureOut">
               <a:rPr lang="de-DE" smtClean="0"/>
-              <a:t>06.10.2025</a:t>
+              <a:t>07.10.2025</a:t>
             </a:fld>
             <a:endParaRPr lang="de-DE"/>
           </a:p>
@@ -1341,7 +1341,7 @@
           <a:p>
             <a:fld id="{ADA51F25-4808-47F4-BF6E-BCDC230DB01C}" type="datetimeFigureOut">
               <a:rPr lang="de-DE" smtClean="0"/>
-              <a:t>06.10.2025</a:t>
+              <a:t>07.10.2025</a:t>
             </a:fld>
             <a:endParaRPr lang="de-DE"/>
           </a:p>
@@ -1539,7 +1539,7 @@
           <a:p>
             <a:fld id="{ADA51F25-4808-47F4-BF6E-BCDC230DB01C}" type="datetimeFigureOut">
               <a:rPr lang="de-DE" smtClean="0"/>
-              <a:t>06.10.2025</a:t>
+              <a:t>07.10.2025</a:t>
             </a:fld>
             <a:endParaRPr lang="de-DE"/>
           </a:p>
@@ -1747,7 +1747,7 @@
           <a:p>
             <a:fld id="{ADA51F25-4808-47F4-BF6E-BCDC230DB01C}" type="datetimeFigureOut">
               <a:rPr lang="de-DE" smtClean="0"/>
-              <a:t>06.10.2025</a:t>
+              <a:t>07.10.2025</a:t>
             </a:fld>
             <a:endParaRPr lang="de-DE"/>
           </a:p>
@@ -1945,7 +1945,7 @@
           <a:p>
             <a:fld id="{ADA51F25-4808-47F4-BF6E-BCDC230DB01C}" type="datetimeFigureOut">
               <a:rPr lang="de-DE" smtClean="0"/>
-              <a:t>06.10.2025</a:t>
+              <a:t>07.10.2025</a:t>
             </a:fld>
             <a:endParaRPr lang="de-DE"/>
           </a:p>
@@ -2220,7 +2220,7 @@
           <a:p>
             <a:fld id="{ADA51F25-4808-47F4-BF6E-BCDC230DB01C}" type="datetimeFigureOut">
               <a:rPr lang="de-DE" smtClean="0"/>
-              <a:t>06.10.2025</a:t>
+              <a:t>07.10.2025</a:t>
             </a:fld>
             <a:endParaRPr lang="de-DE"/>
           </a:p>
@@ -2485,7 +2485,7 @@
           <a:p>
             <a:fld id="{ADA51F25-4808-47F4-BF6E-BCDC230DB01C}" type="datetimeFigureOut">
               <a:rPr lang="de-DE" smtClean="0"/>
-              <a:t>06.10.2025</a:t>
+              <a:t>07.10.2025</a:t>
             </a:fld>
             <a:endParaRPr lang="de-DE"/>
           </a:p>
@@ -2897,7 +2897,7 @@
           <a:p>
             <a:fld id="{ADA51F25-4808-47F4-BF6E-BCDC230DB01C}" type="datetimeFigureOut">
               <a:rPr lang="de-DE" smtClean="0"/>
-              <a:t>06.10.2025</a:t>
+              <a:t>07.10.2025</a:t>
             </a:fld>
             <a:endParaRPr lang="de-DE"/>
           </a:p>
@@ -3038,7 +3038,7 @@
           <a:p>
             <a:fld id="{ADA51F25-4808-47F4-BF6E-BCDC230DB01C}" type="datetimeFigureOut">
               <a:rPr lang="de-DE" smtClean="0"/>
-              <a:t>06.10.2025</a:t>
+              <a:t>07.10.2025</a:t>
             </a:fld>
             <a:endParaRPr lang="de-DE"/>
           </a:p>
@@ -3151,7 +3151,7 @@
           <a:p>
             <a:fld id="{ADA51F25-4808-47F4-BF6E-BCDC230DB01C}" type="datetimeFigureOut">
               <a:rPr lang="de-DE" smtClean="0"/>
-              <a:t>06.10.2025</a:t>
+              <a:t>07.10.2025</a:t>
             </a:fld>
             <a:endParaRPr lang="de-DE"/>
           </a:p>
@@ -3462,7 +3462,7 @@
           <a:p>
             <a:fld id="{ADA51F25-4808-47F4-BF6E-BCDC230DB01C}" type="datetimeFigureOut">
               <a:rPr lang="de-DE" smtClean="0"/>
-              <a:t>06.10.2025</a:t>
+              <a:t>07.10.2025</a:t>
             </a:fld>
             <a:endParaRPr lang="de-DE"/>
           </a:p>
@@ -3750,7 +3750,7 @@
           <a:p>
             <a:fld id="{ADA51F25-4808-47F4-BF6E-BCDC230DB01C}" type="datetimeFigureOut">
               <a:rPr lang="de-DE" smtClean="0"/>
-              <a:t>06.10.2025</a:t>
+              <a:t>07.10.2025</a:t>
             </a:fld>
             <a:endParaRPr lang="de-DE"/>
           </a:p>
@@ -3991,7 +3991,7 @@
           <a:p>
             <a:fld id="{ADA51F25-4808-47F4-BF6E-BCDC230DB01C}" type="datetimeFigureOut">
               <a:rPr lang="de-DE" smtClean="0"/>
-              <a:t>06.10.2025</a:t>
+              <a:t>07.10.2025</a:t>
             </a:fld>
             <a:endParaRPr lang="de-DE"/>
           </a:p>
@@ -4506,7 +4506,7 @@
           <a:p>
             <a:r>
               <a:rPr lang="en-US" noProof="0" dirty="0"/>
-              <a:t>08.10.2025</a:t>
+              <a:t>09.10.2025</a:t>
             </a:r>
           </a:p>
         </p:txBody>

</xml_diff>